<commit_message>
CKD-629 Revise MHS Indicator Interpretation Language Per CDC Feedback
</commit_message>
<xml_diff>
--- a/CKDSurveillance/PPT/Q756.pptx
+++ b/CKDSurveillance/PPT/Q756.pptx
@@ -2,17 +2,17 @@
 <file path=ppt/presentation.xml><?xml version="1.0" encoding="utf-8"?>
 <p:presentation xmlns:a="http://schemas.openxmlformats.org/drawingml/2006/main" xmlns:r="http://schemas.openxmlformats.org/officeDocument/2006/relationships" xmlns:p="http://schemas.openxmlformats.org/presentationml/2006/main" saveSubsetFonts="1">
   <p:sldMasterIdLst>
-    <p:sldMasterId id="2147483660" r:id="rId1"/>
+    <p:sldMasterId id="2147483660" r:id="rId4"/>
   </p:sldMasterIdLst>
   <p:sldIdLst>
-    <p:sldId id="256" r:id="rId2"/>
-    <p:sldId id="257" r:id="rId3"/>
-    <p:sldId id="258" r:id="rId4"/>
-    <p:sldId id="259" r:id="rId5"/>
-    <p:sldId id="260" r:id="rId6"/>
-    <p:sldId id="261" r:id="rId7"/>
-    <p:sldId id="262" r:id="rId8"/>
-    <p:sldId id="263" r:id="rId9"/>
+    <p:sldId id="256" r:id="rId5"/>
+    <p:sldId id="257" r:id="rId6"/>
+    <p:sldId id="258" r:id="rId7"/>
+    <p:sldId id="259" r:id="rId8"/>
+    <p:sldId id="260" r:id="rId9"/>
+    <p:sldId id="261" r:id="rId10"/>
+    <p:sldId id="262" r:id="rId11"/>
+    <p:sldId id="263" r:id="rId12"/>
   </p:sldIdLst>
   <p:sldSz cx="12192000" cy="6858000"/>
   <p:notesSz cx="6858000" cy="9144000"/>
@@ -468,6 +468,7 @@
     </c:plotArea>
     <c:plotVisOnly val="1"/>
     <c:dispBlanksAs val="gap"/>
+    <c:showDLblsOverMax val="0"/>
     <c:extLst>
       <c:ext xmlns:c16r3="http://schemas.microsoft.com/office/drawing/2017/03/chart" uri="{56B9EC1D-385E-4148-901F-78D8002777C0}">
         <c16r3:dataDisplayOptions16>
@@ -475,7 +476,6 @@
         </c16r3:dataDisplayOptions16>
       </c:ext>
     </c:extLst>
-    <c:showDLblsOverMax val="0"/>
   </c:chart>
   <c:spPr>
     <a:noFill/>
@@ -885,6 +885,7 @@
     </c:plotArea>
     <c:plotVisOnly val="1"/>
     <c:dispBlanksAs val="gap"/>
+    <c:showDLblsOverMax val="0"/>
     <c:extLst>
       <c:ext xmlns:c16r3="http://schemas.microsoft.com/office/drawing/2017/03/chart" uri="{56B9EC1D-385E-4148-901F-78D8002777C0}">
         <c16r3:dataDisplayOptions16>
@@ -892,7 +893,6 @@
         </c16r3:dataDisplayOptions16>
       </c:ext>
     </c:extLst>
-    <c:showDLblsOverMax val="0"/>
   </c:chart>
   <c:spPr>
     <a:noFill/>
@@ -2225,6 +2225,7 @@
     </c:legend>
     <c:plotVisOnly val="1"/>
     <c:dispBlanksAs val="gap"/>
+    <c:showDLblsOverMax val="0"/>
     <c:extLst>
       <c:ext xmlns:c16r3="http://schemas.microsoft.com/office/drawing/2017/03/chart" uri="{56B9EC1D-385E-4148-901F-78D8002777C0}">
         <c16r3:dataDisplayOptions16>
@@ -2232,7 +2233,6 @@
         </c16r3:dataDisplayOptions16>
       </c:ext>
     </c:extLst>
-    <c:showDLblsOverMax val="0"/>
   </c:chart>
   <c:spPr>
     <a:noFill/>
@@ -2944,6 +2944,7 @@
     </c:legend>
     <c:plotVisOnly val="1"/>
     <c:dispBlanksAs val="gap"/>
+    <c:showDLblsOverMax val="0"/>
     <c:extLst>
       <c:ext xmlns:c16r3="http://schemas.microsoft.com/office/drawing/2017/03/chart" uri="{56B9EC1D-385E-4148-901F-78D8002777C0}">
         <c16r3:dataDisplayOptions16>
@@ -2951,7 +2952,6 @@
         </c16r3:dataDisplayOptions16>
       </c:ext>
     </c:extLst>
-    <c:showDLblsOverMax val="0"/>
   </c:chart>
   <c:spPr>
     <a:noFill/>
@@ -3671,6 +3671,7 @@
     </c:legend>
     <c:plotVisOnly val="1"/>
     <c:dispBlanksAs val="gap"/>
+    <c:showDLblsOverMax val="0"/>
     <c:extLst>
       <c:ext xmlns:c16r3="http://schemas.microsoft.com/office/drawing/2017/03/chart" uri="{56B9EC1D-385E-4148-901F-78D8002777C0}">
         <c16r3:dataDisplayOptions16>
@@ -3678,7 +3679,6 @@
         </c16r3:dataDisplayOptions16>
       </c:ext>
     </c:extLst>
-    <c:showDLblsOverMax val="0"/>
   </c:chart>
   <c:spPr>
     <a:noFill/>
@@ -4195,7 +4195,7 @@
               <c:strCache>
                 <c:ptCount val="1"/>
                 <c:pt idx="0">
-                  <c:v>Asian/Pacific Islander</c:v>
+                  <c:v>Asian American/Pacific Islander</c:v>
                 </c:pt>
               </c:strCache>
             </c:strRef>
@@ -4859,6 +4859,7 @@
     </c:legend>
     <c:plotVisOnly val="1"/>
     <c:dispBlanksAs val="gap"/>
+    <c:showDLblsOverMax val="0"/>
     <c:extLst>
       <c:ext xmlns:c16r3="http://schemas.microsoft.com/office/drawing/2017/03/chart" uri="{56B9EC1D-385E-4148-901F-78D8002777C0}">
         <c16r3:dataDisplayOptions16>
@@ -4866,7 +4867,6 @@
         </c16r3:dataDisplayOptions16>
       </c:ext>
     </c:extLst>
-    <c:showDLblsOverMax val="0"/>
   </c:chart>
   <c:spPr>
     <a:noFill/>
@@ -5383,7 +5383,7 @@
               <c:strCache>
                 <c:ptCount val="1"/>
                 <c:pt idx="0">
-                  <c:v>Asian/Pacific Islander</c:v>
+                  <c:v>Asian American/Pacific Islander</c:v>
                 </c:pt>
               </c:strCache>
             </c:strRef>
@@ -6047,6 +6047,7 @@
     </c:legend>
     <c:plotVisOnly val="1"/>
     <c:dispBlanksAs val="gap"/>
+    <c:showDLblsOverMax val="0"/>
     <c:extLst>
       <c:ext xmlns:c16r3="http://schemas.microsoft.com/office/drawing/2017/03/chart" uri="{56B9EC1D-385E-4148-901F-78D8002777C0}">
         <c16r3:dataDisplayOptions16>
@@ -6054,7 +6055,6 @@
         </c16r3:dataDisplayOptions16>
       </c:ext>
     </c:extLst>
-    <c:showDLblsOverMax val="0"/>
   </c:chart>
   <c:spPr>
     <a:noFill/>
@@ -10242,7 +10242,7 @@
           <a:p>
             <a:fld id="{5BA7D939-328E-4FDC-8520-F2EE74C8E8C4}" type="datetimeFigureOut">
               <a:rPr lang="en-US" smtClean="0"/>
-              <a:t>12/23/2025</a:t>
+              <a:t>5/13/2026</a:t>
             </a:fld>
             <a:endParaRPr lang="en-US"/>
           </a:p>
@@ -10450,7 +10450,7 @@
           <a:p>
             <a:fld id="{5BA7D939-328E-4FDC-8520-F2EE74C8E8C4}" type="datetimeFigureOut">
               <a:rPr lang="en-US" smtClean="0"/>
-              <a:t>12/23/2025</a:t>
+              <a:t>5/13/2026</a:t>
             </a:fld>
             <a:endParaRPr lang="en-US"/>
           </a:p>
@@ -10659,7 +10659,7 @@
           <a:p>
             <a:fld id="{5BA7D939-328E-4FDC-8520-F2EE74C8E8C4}" type="datetimeFigureOut">
               <a:rPr lang="en-US" smtClean="0"/>
-              <a:t>12/23/2025</a:t>
+              <a:t>5/13/2026</a:t>
             </a:fld>
             <a:endParaRPr lang="en-US"/>
           </a:p>
@@ -10974,7 +10974,7 @@
           <a:p>
             <a:fld id="{5BA7D939-328E-4FDC-8520-F2EE74C8E8C4}" type="datetimeFigureOut">
               <a:rPr lang="en-US" smtClean="0"/>
-              <a:t>12/23/2025</a:t>
+              <a:t>5/13/2026</a:t>
             </a:fld>
             <a:endParaRPr lang="en-US"/>
           </a:p>
@@ -11280,7 +11280,7 @@
           <a:p>
             <a:fld id="{5BA7D939-328E-4FDC-8520-F2EE74C8E8C4}" type="datetimeFigureOut">
               <a:rPr lang="en-US" smtClean="0"/>
-              <a:t>12/23/2025</a:t>
+              <a:t>5/13/2026</a:t>
             </a:fld>
             <a:endParaRPr lang="en-US"/>
           </a:p>
@@ -11728,7 +11728,7 @@
           <a:p>
             <a:fld id="{5BA7D939-328E-4FDC-8520-F2EE74C8E8C4}" type="datetimeFigureOut">
               <a:rPr lang="en-US" smtClean="0"/>
-              <a:t>12/23/2025</a:t>
+              <a:t>5/13/2026</a:t>
             </a:fld>
             <a:endParaRPr lang="en-US"/>
           </a:p>
@@ -11910,7 +11910,7 @@
           <a:p>
             <a:fld id="{5BA7D939-328E-4FDC-8520-F2EE74C8E8C4}" type="datetimeFigureOut">
               <a:rPr lang="en-US" smtClean="0"/>
-              <a:t>12/23/2025</a:t>
+              <a:t>5/13/2026</a:t>
             </a:fld>
             <a:endParaRPr lang="en-US"/>
           </a:p>
@@ -12059,7 +12059,7 @@
           <a:p>
             <a:fld id="{5BA7D939-328E-4FDC-8520-F2EE74C8E8C4}" type="datetimeFigureOut">
               <a:rPr lang="en-US" smtClean="0"/>
-              <a:t>12/23/2025</a:t>
+              <a:t>5/13/2026</a:t>
             </a:fld>
             <a:endParaRPr lang="en-US"/>
           </a:p>
@@ -12407,7 +12407,7 @@
           <a:p>
             <a:fld id="{5BA7D939-328E-4FDC-8520-F2EE74C8E8C4}" type="datetimeFigureOut">
               <a:rPr lang="en-US" smtClean="0"/>
-              <a:t>12/23/2025</a:t>
+              <a:t>5/13/2026</a:t>
             </a:fld>
             <a:endParaRPr lang="en-US"/>
           </a:p>
@@ -12735,7 +12735,7 @@
           <a:p>
             <a:fld id="{5BA7D939-328E-4FDC-8520-F2EE74C8E8C4}" type="datetimeFigureOut">
               <a:rPr lang="en-US" smtClean="0"/>
-              <a:t>12/23/2025</a:t>
+              <a:t>5/13/2026</a:t>
             </a:fld>
             <a:endParaRPr lang="en-US"/>
           </a:p>
@@ -13013,7 +13013,7 @@
           <a:p>
             <a:fld id="{5BA7D939-328E-4FDC-8520-F2EE74C8E8C4}" type="datetimeFigureOut">
               <a:rPr lang="en-US" smtClean="0"/>
-              <a:t>12/23/2025</a:t>
+              <a:t>5/13/2026</a:t>
             </a:fld>
             <a:endParaRPr lang="en-US"/>
           </a:p>
@@ -13488,108 +13488,114 @@
           <a:p>
             <a:pPr algn="l"/>
             <a:r>
-              <a:rPr lang="en-US" sz="1800" dirty="0">
+              <a:rPr lang="en-US" sz="2000" dirty="0">
                 <a:effectLst/>
-                <a:latin typeface="Calibri" panose="020F0502020204030204" pitchFamily="34" charset="0"/>
+                <a:latin typeface="+mn-lt"/>
                 <a:ea typeface="Times New Roman" panose="02020603050405020304" pitchFamily="18" charset="0"/>
               </a:rPr>
               <a:t>The crude prevalence of Military Health System (MHS) beneficiaries with CKD stages 3–5 (estimated glomerular filtration rate [eGFR] &lt;60 ml/min/1.73</a:t>
             </a:r>
             <a:r>
-              <a:rPr lang="en-US" sz="1800" baseline="30000" dirty="0">
+              <a:rPr lang="en-US" sz="2000" baseline="30000" dirty="0">
                 <a:effectLst/>
-                <a:latin typeface="Calibri" panose="020F0502020204030204" pitchFamily="34" charset="0"/>
+                <a:latin typeface="+mn-lt"/>
                 <a:ea typeface="Times New Roman" panose="02020603050405020304" pitchFamily="18" charset="0"/>
               </a:rPr>
               <a:t>2</a:t>
             </a:r>
             <a:r>
-              <a:rPr lang="en-US" sz="1800" dirty="0">
+              <a:rPr lang="en-US" sz="2000" dirty="0">
                 <a:effectLst/>
-                <a:latin typeface="Calibri" panose="020F0502020204030204" pitchFamily="34" charset="0"/>
+                <a:latin typeface="+mn-lt"/>
                 <a:ea typeface="Times New Roman" panose="02020603050405020304" pitchFamily="18" charset="0"/>
               </a:rPr>
               <a:t>) ranged from 5.9% to 4.</a:t>
             </a:r>
             <a:r>
-              <a:rPr lang="en-US" sz="1800" dirty="0">
+              <a:rPr lang="en-US" sz="2000" dirty="0">
                 <a:effectLst/>
-                <a:latin typeface="Calibri" panose="020F0502020204030204" pitchFamily="34" charset="0"/>
+                <a:latin typeface="+mn-lt"/>
                 <a:ea typeface="Malgun Gothic" panose="020B0503020000020004" pitchFamily="34" charset="-127"/>
               </a:rPr>
               <a:t>8</a:t>
             </a:r>
             <a:r>
-              <a:rPr lang="en-US" sz="1800" dirty="0">
+              <a:rPr lang="en-US" sz="2000" dirty="0">
                 <a:effectLst/>
-                <a:latin typeface="Calibri" panose="020F0502020204030204" pitchFamily="34" charset="0"/>
+                <a:latin typeface="+mn-lt"/>
                 <a:ea typeface="Times New Roman" panose="02020603050405020304" pitchFamily="18" charset="0"/>
               </a:rPr>
               <a:t>% during 2009–202</a:t>
             </a:r>
             <a:r>
-              <a:rPr lang="en-US" sz="1800" dirty="0">
+              <a:rPr lang="en-US" sz="2000" dirty="0">
                 <a:effectLst/>
-                <a:latin typeface="Calibri" panose="020F0502020204030204" pitchFamily="34" charset="0"/>
+                <a:latin typeface="+mn-lt"/>
                 <a:ea typeface="Malgun Gothic" panose="020B0503020000020004" pitchFamily="34" charset="-127"/>
               </a:rPr>
               <a:t>3</a:t>
             </a:r>
             <a:r>
-              <a:rPr lang="en-US" sz="1800" dirty="0">
+              <a:rPr lang="en-US" sz="2000" dirty="0">
                 <a:effectLst/>
-                <a:latin typeface="Calibri" panose="020F0502020204030204" pitchFamily="34" charset="0"/>
+                <a:latin typeface="+mn-lt"/>
                 <a:ea typeface="Times New Roman" panose="02020603050405020304" pitchFamily="18" charset="0"/>
               </a:rPr>
               <a:t>. The age-standardized prevalence decreased from </a:t>
             </a:r>
             <a:r>
-              <a:rPr lang="en-US" sz="1800" dirty="0">
+              <a:rPr lang="en-US" sz="2000" dirty="0">
                 <a:effectLst/>
-                <a:latin typeface="Calibri" panose="020F0502020204030204" pitchFamily="34" charset="0"/>
+                <a:latin typeface="+mn-lt"/>
                 <a:ea typeface="Malgun Gothic" panose="020B0503020000020004" pitchFamily="34" charset="-127"/>
               </a:rPr>
               <a:t>7.7</a:t>
             </a:r>
             <a:r>
-              <a:rPr lang="en-US" sz="1800" dirty="0">
+              <a:rPr lang="en-US" sz="2000" dirty="0">
                 <a:effectLst/>
-                <a:latin typeface="Calibri" panose="020F0502020204030204" pitchFamily="34" charset="0"/>
+                <a:latin typeface="+mn-lt"/>
                 <a:ea typeface="Times New Roman" panose="02020603050405020304" pitchFamily="18" charset="0"/>
               </a:rPr>
               <a:t>% to 5.6%. The crude prevalence of CKD stages 3–5 was highest in adults aged ≥70 years and Black adults</a:t>
             </a:r>
             <a:r>
-              <a:rPr lang="en-US" sz="1800" dirty="0">
+              <a:rPr lang="en-US" sz="2000" dirty="0">
                 <a:effectLst/>
-                <a:latin typeface="Calibri" panose="020F0502020204030204" pitchFamily="34" charset="0"/>
+                <a:latin typeface="+mn-lt"/>
                 <a:ea typeface="Malgun Gothic" panose="020B0503020000020004" pitchFamily="34" charset="-127"/>
               </a:rPr>
               <a:t> (among those with known race and ethnicity)</a:t>
             </a:r>
             <a:r>
-              <a:rPr lang="en-US" sz="1800" dirty="0">
+              <a:rPr lang="en-US" sz="2000" dirty="0">
                 <a:effectLst/>
-                <a:latin typeface="Calibri" panose="020F0502020204030204" pitchFamily="34" charset="0"/>
+                <a:latin typeface="+mn-lt"/>
                 <a:ea typeface="Times New Roman" panose="02020603050405020304" pitchFamily="18" charset="0"/>
               </a:rPr>
-              <a:t>. The age-standardized prevalence was highest in Black adults compared with their counterparts. </a:t>
+              <a:t>. The age-standardized prevalence was higher in Black adults compared with their counterparts. </a:t>
             </a:r>
-            <a:endParaRPr lang="en-US" dirty="0">
-              <a:latin typeface="Calibri" panose="020F0502020204030204" pitchFamily="34" charset="0"/>
+            <a:endParaRPr lang="en-US" sz="2000" dirty="0">
+              <a:latin typeface="+mn-lt"/>
             </a:endParaRPr>
           </a:p>
           <a:p>
             <a:pPr algn="l"/>
             <a:r>
-              <a:rPr lang="en-US" b="1" dirty="0"/>
+              <a:rPr lang="en-US" sz="2000" b="1" dirty="0">
+                <a:latin typeface="+mn-lt"/>
+              </a:rPr>
               <a:t>Data Source: </a:t>
             </a:r>
             <a:r>
-              <a:rPr lang="en-US" dirty="0"/>
-              <a:t>DoD-MHS</a:t>
+              <a:rPr lang="en-US" sz="2000" dirty="0">
+                <a:latin typeface="+mn-lt"/>
+              </a:rPr>
+              <a:t>MHS</a:t>
             </a:r>
-            <a:endParaRPr lang="en-US" b="1" dirty="0"/>
+            <a:endParaRPr lang="en-US" sz="2000" b="1" dirty="0">
+              <a:latin typeface="+mn-lt"/>
+            </a:endParaRPr>
           </a:p>
         </p:txBody>
       </p:sp>
@@ -14191,7 +14197,7 @@
           <p:nvPr>
             <p:extLst>
               <p:ext uri="{D42A27DB-BD31-4B8C-83A1-F6EECF244321}">
-                <p14:modId xmlns:p14="http://schemas.microsoft.com/office/powerpoint/2010/main" val="1312897891"/>
+                <p14:modId xmlns:p14="http://schemas.microsoft.com/office/powerpoint/2010/main" val="274363723"/>
               </p:ext>
             </p:extLst>
           </p:nvPr>
@@ -14286,7 +14292,7 @@
           <p:nvPr>
             <p:extLst>
               <p:ext uri="{D42A27DB-BD31-4B8C-83A1-F6EECF244321}">
-                <p14:modId xmlns:p14="http://schemas.microsoft.com/office/powerpoint/2010/main" val="1271153685"/>
+                <p14:modId xmlns:p14="http://schemas.microsoft.com/office/powerpoint/2010/main" val="2293839170"/>
               </p:ext>
             </p:extLst>
           </p:nvPr>
@@ -14607,4 +14613,251 @@
     </a:ext>
   </a:extLst>
 </a:theme>
+</file>
+
+<file path=customXml/item1.xml><?xml version="1.0" encoding="utf-8"?>
+<p:properties xmlns:p="http://schemas.microsoft.com/office/2006/metadata/properties" xmlns:xsi="http://www.w3.org/2001/XMLSchema-instance" xmlns:pc="http://schemas.microsoft.com/office/infopath/2007/PartnerControls">
+  <documentManagement>
+    <lcf76f155ced4ddcb4097134ff3c332f xmlns="5749bc8e-1545-4b42-a651-f1b0ccdc5fa5">
+      <Terms xmlns="http://schemas.microsoft.com/office/infopath/2007/PartnerControls"/>
+    </lcf76f155ced4ddcb4097134ff3c332f>
+    <TaxCatchAll xmlns="8e022c51-0240-47ac-b7b0-09a2f3086777" xsi:nil="true"/>
+  </documentManagement>
+</p:properties>
+</file>
+
+<file path=customXml/item2.xml><?xml version="1.0" encoding="utf-8"?>
+<?mso-contentType ?>
+<FormTemplates xmlns="http://schemas.microsoft.com/sharepoint/v3/contenttype/forms">
+  <Display>DocumentLibraryForm</Display>
+  <Edit>DocumentLibraryForm</Edit>
+  <New>DocumentLibraryForm</New>
+</FormTemplates>
+</file>
+
+<file path=customXml/item3.xml><?xml version="1.0" encoding="utf-8"?>
+<ct:contentTypeSchema xmlns:ct="http://schemas.microsoft.com/office/2006/metadata/contentType" xmlns:ma="http://schemas.microsoft.com/office/2006/metadata/properties/metaAttributes" ct:_="" ma:_="" ma:contentTypeName="Document" ma:contentTypeID="0x01010050BC9B24C2BC4648A822105B302116B0" ma:contentTypeVersion="10" ma:contentTypeDescription="Create a new document." ma:contentTypeScope="" ma:versionID="581fb2d9703863f3db532522de69a7d8">
+  <xsd:schema xmlns:xsd="http://www.w3.org/2001/XMLSchema" xmlns:xs="http://www.w3.org/2001/XMLSchema" xmlns:p="http://schemas.microsoft.com/office/2006/metadata/properties" xmlns:ns2="5749bc8e-1545-4b42-a651-f1b0ccdc5fa5" xmlns:ns3="8e022c51-0240-47ac-b7b0-09a2f3086777" targetNamespace="http://schemas.microsoft.com/office/2006/metadata/properties" ma:root="true" ma:fieldsID="96cb22f3222442646e545c3c1fc94001" ns2:_="" ns3:_="">
+    <xsd:import namespace="5749bc8e-1545-4b42-a651-f1b0ccdc5fa5"/>
+    <xsd:import namespace="8e022c51-0240-47ac-b7b0-09a2f3086777"/>
+    <xsd:element name="properties">
+      <xsd:complexType>
+        <xsd:sequence>
+          <xsd:element name="documentManagement">
+            <xsd:complexType>
+              <xsd:all>
+                <xsd:element ref="ns2:MediaServiceMetadata" minOccurs="0"/>
+                <xsd:element ref="ns2:MediaServiceFastMetadata" minOccurs="0"/>
+                <xsd:element ref="ns2:MediaServiceSearchProperties" minOccurs="0"/>
+                <xsd:element ref="ns2:MediaServiceDateTaken" minOccurs="0"/>
+                <xsd:element ref="ns2:lcf76f155ced4ddcb4097134ff3c332f" minOccurs="0"/>
+                <xsd:element ref="ns3:TaxCatchAll" minOccurs="0"/>
+                <xsd:element ref="ns2:MediaServiceOCR" minOccurs="0"/>
+                <xsd:element ref="ns2:MediaServiceGenerationTime" minOccurs="0"/>
+                <xsd:element ref="ns2:MediaServiceEventHashCode" minOccurs="0"/>
+              </xsd:all>
+            </xsd:complexType>
+          </xsd:element>
+        </xsd:sequence>
+      </xsd:complexType>
+    </xsd:element>
+  </xsd:schema>
+  <xsd:schema xmlns:xsd="http://www.w3.org/2001/XMLSchema" xmlns:xs="http://www.w3.org/2001/XMLSchema" xmlns:dms="http://schemas.microsoft.com/office/2006/documentManagement/types" xmlns:pc="http://schemas.microsoft.com/office/infopath/2007/PartnerControls" targetNamespace="5749bc8e-1545-4b42-a651-f1b0ccdc5fa5" elementFormDefault="qualified">
+    <xsd:import namespace="http://schemas.microsoft.com/office/2006/documentManagement/types"/>
+    <xsd:import namespace="http://schemas.microsoft.com/office/infopath/2007/PartnerControls"/>
+    <xsd:element name="MediaServiceMetadata" ma:index="8" nillable="true" ma:displayName="MediaServiceMetadata" ma:hidden="true" ma:internalName="MediaServiceMetadata" ma:readOnly="true">
+      <xsd:simpleType>
+        <xsd:restriction base="dms:Note"/>
+      </xsd:simpleType>
+    </xsd:element>
+    <xsd:element name="MediaServiceFastMetadata" ma:index="9" nillable="true" ma:displayName="MediaServiceFastMetadata" ma:hidden="true" ma:internalName="MediaServiceFastMetadata" ma:readOnly="true">
+      <xsd:simpleType>
+        <xsd:restriction base="dms:Note"/>
+      </xsd:simpleType>
+    </xsd:element>
+    <xsd:element name="MediaServiceSearchProperties" ma:index="10" nillable="true" ma:displayName="MediaServiceSearchProperties" ma:hidden="true" ma:internalName="MediaServiceSearchProperties" ma:readOnly="true">
+      <xsd:simpleType>
+        <xsd:restriction base="dms:Note"/>
+      </xsd:simpleType>
+    </xsd:element>
+    <xsd:element name="MediaServiceDateTaken" ma:index="11" nillable="true" ma:displayName="MediaServiceDateTaken" ma:hidden="true" ma:indexed="true" ma:internalName="MediaServiceDateTaken" ma:readOnly="true">
+      <xsd:simpleType>
+        <xsd:restriction base="dms:Text"/>
+      </xsd:simpleType>
+    </xsd:element>
+    <xsd:element name="lcf76f155ced4ddcb4097134ff3c332f" ma:index="13" nillable="true" ma:taxonomy="true" ma:internalName="lcf76f155ced4ddcb4097134ff3c332f" ma:taxonomyFieldName="MediaServiceImageTags" ma:displayName="Image Tags" ma:readOnly="false" ma:fieldId="{5cf76f15-5ced-4ddc-b409-7134ff3c332f}" ma:taxonomyMulti="true" ma:sspId="cae6c5d7-b21f-4aaa-ac91-296ecc6194c0" ma:termSetId="09814cd3-568e-fe90-9814-8d621ff8fb84" ma:anchorId="fba54fb3-c3e1-fe81-a776-ca4b69148c4d" ma:open="true" ma:isKeyword="false">
+      <xsd:complexType>
+        <xsd:sequence>
+          <xsd:element ref="pc:Terms" minOccurs="0" maxOccurs="1"/>
+        </xsd:sequence>
+      </xsd:complexType>
+    </xsd:element>
+    <xsd:element name="MediaServiceOCR" ma:index="15" nillable="true" ma:displayName="Extracted Text" ma:internalName="MediaServiceOCR" ma:readOnly="true">
+      <xsd:simpleType>
+        <xsd:restriction base="dms:Note">
+          <xsd:maxLength value="255"/>
+        </xsd:restriction>
+      </xsd:simpleType>
+    </xsd:element>
+    <xsd:element name="MediaServiceGenerationTime" ma:index="16" nillable="true" ma:displayName="MediaServiceGenerationTime" ma:hidden="true" ma:internalName="MediaServiceGenerationTime" ma:readOnly="true">
+      <xsd:simpleType>
+        <xsd:restriction base="dms:Text"/>
+      </xsd:simpleType>
+    </xsd:element>
+    <xsd:element name="MediaServiceEventHashCode" ma:index="17" nillable="true" ma:displayName="MediaServiceEventHashCode" ma:hidden="true" ma:internalName="MediaServiceEventHashCode" ma:readOnly="true">
+      <xsd:simpleType>
+        <xsd:restriction base="dms:Text"/>
+      </xsd:simpleType>
+    </xsd:element>
+  </xsd:schema>
+  <xsd:schema xmlns:xsd="http://www.w3.org/2001/XMLSchema" xmlns:xs="http://www.w3.org/2001/XMLSchema" xmlns:dms="http://schemas.microsoft.com/office/2006/documentManagement/types" xmlns:pc="http://schemas.microsoft.com/office/infopath/2007/PartnerControls" targetNamespace="8e022c51-0240-47ac-b7b0-09a2f3086777" elementFormDefault="qualified">
+    <xsd:import namespace="http://schemas.microsoft.com/office/2006/documentManagement/types"/>
+    <xsd:import namespace="http://schemas.microsoft.com/office/infopath/2007/PartnerControls"/>
+    <xsd:element name="TaxCatchAll" ma:index="14" nillable="true" ma:displayName="Taxonomy Catch All Column" ma:hidden="true" ma:list="{4f07c378-3462-46dc-a28e-833745c64bfd}" ma:internalName="TaxCatchAll" ma:showField="CatchAllData" ma:web="8e022c51-0240-47ac-b7b0-09a2f3086777">
+      <xsd:complexType>
+        <xsd:complexContent>
+          <xsd:extension base="dms:MultiChoiceLookup">
+            <xsd:sequence>
+              <xsd:element name="Value" type="dms:Lookup" maxOccurs="unbounded" minOccurs="0" nillable="true"/>
+            </xsd:sequence>
+          </xsd:extension>
+        </xsd:complexContent>
+      </xsd:complexType>
+    </xsd:element>
+  </xsd:schema>
+  <xsd:schema xmlns="http://schemas.openxmlformats.org/package/2006/metadata/core-properties" xmlns:xsd="http://www.w3.org/2001/XMLSchema" xmlns:xsi="http://www.w3.org/2001/XMLSchema-instance" xmlns:dc="http://purl.org/dc/elements/1.1/" xmlns:dcterms="http://purl.org/dc/terms/" xmlns:odoc="http://schemas.microsoft.com/internal/obd" targetNamespace="http://schemas.openxmlformats.org/package/2006/metadata/core-properties" elementFormDefault="qualified" attributeFormDefault="unqualified" blockDefault="#all">
+    <xsd:import namespace="http://purl.org/dc/elements/1.1/" schemaLocation="http://dublincore.org/schemas/xmls/qdc/2003/04/02/dc.xsd"/>
+    <xsd:import namespace="http://purl.org/dc/terms/" schemaLocation="http://dublincore.org/schemas/xmls/qdc/2003/04/02/dcterms.xsd"/>
+    <xsd:element name="coreProperties" type="CT_coreProperties"/>
+    <xsd:complexType name="CT_coreProperties">
+      <xsd:all>
+        <xsd:element ref="dc:creator" minOccurs="0" maxOccurs="1"/>
+        <xsd:element ref="dcterms:created" minOccurs="0" maxOccurs="1"/>
+        <xsd:element ref="dc:identifier" minOccurs="0" maxOccurs="1"/>
+        <xsd:element name="contentType" minOccurs="0" maxOccurs="1" type="xsd:string" ma:index="0" ma:displayName="Content Type"/>
+        <xsd:element ref="dc:title" minOccurs="0" maxOccurs="1" ma:index="4" ma:displayName="Title"/>
+        <xsd:element ref="dc:subject" minOccurs="0" maxOccurs="1"/>
+        <xsd:element ref="dc:description" minOccurs="0" maxOccurs="1"/>
+        <xsd:element name="keywords" minOccurs="0" maxOccurs="1" type="xsd:string"/>
+        <xsd:element ref="dc:language" minOccurs="0" maxOccurs="1"/>
+        <xsd:element name="category" minOccurs="0" maxOccurs="1" type="xsd:string"/>
+        <xsd:element name="version" minOccurs="0" maxOccurs="1" type="xsd:string"/>
+        <xsd:element name="revision" minOccurs="0" maxOccurs="1" type="xsd:string">
+          <xsd:annotation>
+            <xsd:documentation>
+                        This value indicates the number of saves or revisions. The application is responsible for updating this value after each revision.
+                    </xsd:documentation>
+          </xsd:annotation>
+        </xsd:element>
+        <xsd:element name="lastModifiedBy" minOccurs="0" maxOccurs="1" type="xsd:string"/>
+        <xsd:element ref="dcterms:modified" minOccurs="0" maxOccurs="1"/>
+        <xsd:element name="contentStatus" minOccurs="0" maxOccurs="1" type="xsd:string"/>
+      </xsd:all>
+    </xsd:complexType>
+  </xsd:schema>
+  <xs:schema xmlns:pc="http://schemas.microsoft.com/office/infopath/2007/PartnerControls" xmlns:xs="http://www.w3.org/2001/XMLSchema" targetNamespace="http://schemas.microsoft.com/office/infopath/2007/PartnerControls" elementFormDefault="qualified" attributeFormDefault="unqualified">
+    <xs:element name="Person">
+      <xs:complexType>
+        <xs:sequence>
+          <xs:element ref="pc:DisplayName" minOccurs="0"/>
+          <xs:element ref="pc:AccountId" minOccurs="0"/>
+          <xs:element ref="pc:AccountType" minOccurs="0"/>
+        </xs:sequence>
+      </xs:complexType>
+    </xs:element>
+    <xs:element name="DisplayName" type="xs:string"/>
+    <xs:element name="AccountId" type="xs:string"/>
+    <xs:element name="AccountType" type="xs:string"/>
+    <xs:element name="BDCAssociatedEntity">
+      <xs:complexType>
+        <xs:sequence>
+          <xs:element ref="pc:BDCEntity" minOccurs="0" maxOccurs="unbounded"/>
+        </xs:sequence>
+        <xs:attribute ref="pc:EntityNamespace"/>
+        <xs:attribute ref="pc:EntityName"/>
+        <xs:attribute ref="pc:SystemInstanceName"/>
+        <xs:attribute ref="pc:AssociationName"/>
+      </xs:complexType>
+    </xs:element>
+    <xs:attribute name="EntityNamespace" type="xs:string"/>
+    <xs:attribute name="EntityName" type="xs:string"/>
+    <xs:attribute name="SystemInstanceName" type="xs:string"/>
+    <xs:attribute name="AssociationName" type="xs:string"/>
+    <xs:element name="BDCEntity">
+      <xs:complexType>
+        <xs:sequence>
+          <xs:element ref="pc:EntityDisplayName" minOccurs="0"/>
+          <xs:element ref="pc:EntityInstanceReference" minOccurs="0"/>
+          <xs:element ref="pc:EntityId1" minOccurs="0"/>
+          <xs:element ref="pc:EntityId2" minOccurs="0"/>
+          <xs:element ref="pc:EntityId3" minOccurs="0"/>
+          <xs:element ref="pc:EntityId4" minOccurs="0"/>
+          <xs:element ref="pc:EntityId5" minOccurs="0"/>
+        </xs:sequence>
+      </xs:complexType>
+    </xs:element>
+    <xs:element name="EntityDisplayName" type="xs:string"/>
+    <xs:element name="EntityInstanceReference" type="xs:string"/>
+    <xs:element name="EntityId1" type="xs:string"/>
+    <xs:element name="EntityId2" type="xs:string"/>
+    <xs:element name="EntityId3" type="xs:string"/>
+    <xs:element name="EntityId4" type="xs:string"/>
+    <xs:element name="EntityId5" type="xs:string"/>
+    <xs:element name="Terms">
+      <xs:complexType>
+        <xs:sequence>
+          <xs:element ref="pc:TermInfo" minOccurs="0" maxOccurs="unbounded"/>
+        </xs:sequence>
+      </xs:complexType>
+    </xs:element>
+    <xs:element name="TermInfo">
+      <xs:complexType>
+        <xs:sequence>
+          <xs:element ref="pc:TermName" minOccurs="0"/>
+          <xs:element ref="pc:TermId" minOccurs="0"/>
+        </xs:sequence>
+      </xs:complexType>
+    </xs:element>
+    <xs:element name="TermName" type="xs:string"/>
+    <xs:element name="TermId" type="xs:string"/>
+  </xs:schema>
+</ct:contentTypeSchema>
+</file>
+
+<file path=customXml/itemProps1.xml><?xml version="1.0" encoding="utf-8"?>
+<ds:datastoreItem xmlns:ds="http://schemas.openxmlformats.org/officeDocument/2006/customXml" ds:itemID="{D10DEA2A-2DDF-474E-9239-B8EC4647655C}">
+  <ds:schemaRefs>
+    <ds:schemaRef ds:uri="http://schemas.microsoft.com/office/2006/metadata/properties"/>
+    <ds:schemaRef ds:uri="http://schemas.microsoft.com/office/infopath/2007/PartnerControls"/>
+    <ds:schemaRef ds:uri="5749bc8e-1545-4b42-a651-f1b0ccdc5fa5"/>
+    <ds:schemaRef ds:uri="8e022c51-0240-47ac-b7b0-09a2f3086777"/>
+  </ds:schemaRefs>
+</ds:datastoreItem>
+</file>
+
+<file path=customXml/itemProps2.xml><?xml version="1.0" encoding="utf-8"?>
+<ds:datastoreItem xmlns:ds="http://schemas.openxmlformats.org/officeDocument/2006/customXml" ds:itemID="{5191AF3F-F6A5-42D5-A276-685BBDEEC7F6}">
+  <ds:schemaRefs>
+    <ds:schemaRef ds:uri="http://schemas.microsoft.com/sharepoint/v3/contenttype/forms"/>
+  </ds:schemaRefs>
+</ds:datastoreItem>
+</file>
+
+<file path=customXml/itemProps3.xml><?xml version="1.0" encoding="utf-8"?>
+<ds:datastoreItem xmlns:ds="http://schemas.openxmlformats.org/officeDocument/2006/customXml" ds:itemID="{FEF6F2BE-E755-4252-85C7-430D64221090}">
+  <ds:schemaRefs>
+    <ds:schemaRef ds:uri="http://schemas.microsoft.com/office/2006/metadata/contentType"/>
+    <ds:schemaRef ds:uri="http://schemas.microsoft.com/office/2006/metadata/properties/metaAttributes"/>
+    <ds:schemaRef ds:uri="http://www.w3.org/2001/XMLSchema"/>
+    <ds:schemaRef ds:uri="http://schemas.microsoft.com/office/2006/metadata/properties"/>
+    <ds:schemaRef ds:uri="5749bc8e-1545-4b42-a651-f1b0ccdc5fa5"/>
+    <ds:schemaRef ds:uri="8e022c51-0240-47ac-b7b0-09a2f3086777"/>
+    <ds:schemaRef ds:uri="http://schemas.microsoft.com/office/2006/documentManagement/types"/>
+    <ds:schemaRef ds:uri="http://schemas.microsoft.com/office/infopath/2007/PartnerControls"/>
+    <ds:schemaRef ds:uri="http://schemas.openxmlformats.org/package/2006/metadata/core-properties"/>
+    <ds:schemaRef ds:uri="http://purl.org/dc/elements/1.1/"/>
+    <ds:schemaRef ds:uri="http://purl.org/dc/terms/"/>
+    <ds:schemaRef ds:uri="http://schemas.microsoft.com/internal/obd"/>
+  </ds:schemaRefs>
+</ds:datastoreItem>
 </file>
</xml_diff>